<commit_message>
feat: add certificate template PPTX files to backend directory
</commit_message>
<xml_diff>
--- a/backend/CERTIFICATE_TEMPLATE - APPRECIATION.pptx
+++ b/backend/CERTIFICATE_TEMPLATE - APPRECIATION.pptx
@@ -5052,9 +5052,55 @@
           </a:p>
         </p:txBody>
       </p:sp>
+      <p:sp>
+        <p:nvSpPr>
+          <p:cNvPr id="41" name="Text Box 40"/>
+          <p:cNvSpPr txBox="1"/>
+          <p:nvPr/>
+        </p:nvSpPr>
+        <p:spPr>
+          <a:xfrm>
+            <a:off x="3829050" y="9561195"/>
+            <a:ext cx="7112000" cy="275590"/>
+          </a:xfrm>
+          <a:prstGeom prst="rect">
+            <a:avLst/>
+          </a:prstGeom>
+          <a:noFill/>
+        </p:spPr>
+        <p:txBody>
+          <a:bodyPr wrap="square" rtlCol="0" anchor="t">
+            <a:spAutoFit/>
+          </a:bodyPr>
+          <a:p>
+            <a:pPr algn="ctr"/>
+            <a:r>
+              <a:rPr lang="en-US" sz="1200" b="1">
+                <a:solidFill>
+                  <a:srgbClr val="C00000"/>
+                </a:solidFill>
+                <a:latin typeface="Cardo Bold" panose="02020804080000020003"/>
+                <a:ea typeface="Cardo Bold" panose="02020804080000020003"/>
+                <a:cs typeface="Cardo Bold" panose="02020804080000020003"/>
+                <a:sym typeface="Cardo Bold" panose="02020804080000020003"/>
+              </a:rPr>
+              <a:t>Certificate ID : TCEK/RD/2026/0001</a:t>
+            </a:r>
+            <a:endParaRPr lang="en-US" sz="1200" b="1">
+              <a:solidFill>
+                <a:srgbClr val="C00000"/>
+              </a:solidFill>
+              <a:latin typeface="Cardo Bold" panose="02020804080000020003"/>
+              <a:ea typeface="Cardo Bold" panose="02020804080000020003"/>
+              <a:cs typeface="Cardo Bold" panose="02020804080000020003"/>
+              <a:sym typeface="Cardo Bold" panose="02020804080000020003"/>
+            </a:endParaRPr>
+          </a:p>
+        </p:txBody>
+      </p:sp>
       <p:pic>
         <p:nvPicPr>
-          <p:cNvPr id="35" name="Picture 34"/>
+          <p:cNvPr id="21" name="Picture 20"/>
           <p:cNvPicPr>
             <a:picLocks noChangeAspect="1"/>
           </p:cNvPicPr>
@@ -5068,60 +5114,14 @@
         </p:blipFill>
         <p:spPr>
           <a:xfrm>
-            <a:off x="2689860" y="749935"/>
-            <a:ext cx="1141730" cy="1077595"/>
+            <a:off x="2686050" y="656590"/>
+            <a:ext cx="1172210" cy="1143000"/>
           </a:xfrm>
           <a:prstGeom prst="rect">
             <a:avLst/>
           </a:prstGeom>
         </p:spPr>
       </p:pic>
-      <p:sp>
-        <p:nvSpPr>
-          <p:cNvPr id="41" name="Text Box 40"/>
-          <p:cNvSpPr txBox="1"/>
-          <p:nvPr/>
-        </p:nvSpPr>
-        <p:spPr>
-          <a:xfrm>
-            <a:off x="3829050" y="9561195"/>
-            <a:ext cx="7112000" cy="275590"/>
-          </a:xfrm>
-          <a:prstGeom prst="rect">
-            <a:avLst/>
-          </a:prstGeom>
-          <a:noFill/>
-        </p:spPr>
-        <p:txBody>
-          <a:bodyPr wrap="square" rtlCol="0" anchor="t">
-            <a:spAutoFit/>
-          </a:bodyPr>
-          <a:p>
-            <a:pPr algn="ctr"/>
-            <a:r>
-              <a:rPr lang="en-US" sz="1200" b="1">
-                <a:solidFill>
-                  <a:srgbClr val="C00000"/>
-                </a:solidFill>
-                <a:latin typeface="Cardo Bold" panose="02020804080000020003"/>
-                <a:ea typeface="Cardo Bold" panose="02020804080000020003"/>
-                <a:cs typeface="Cardo Bold" panose="02020804080000020003"/>
-                <a:sym typeface="Cardo Bold" panose="02020804080000020003"/>
-              </a:rPr>
-              <a:t>Certificate ID : TCEK/RD/2026/0001</a:t>
-            </a:r>
-            <a:endParaRPr lang="en-US" sz="1200" b="1">
-              <a:solidFill>
-                <a:srgbClr val="C00000"/>
-              </a:solidFill>
-              <a:latin typeface="Cardo Bold" panose="02020804080000020003"/>
-              <a:ea typeface="Cardo Bold" panose="02020804080000020003"/>
-              <a:cs typeface="Cardo Bold" panose="02020804080000020003"/>
-              <a:sym typeface="Cardo Bold" panose="02020804080000020003"/>
-            </a:endParaRPr>
-          </a:p>
-        </p:txBody>
-      </p:sp>
     </p:spTree>
   </p:cSld>
   <p:clrMapOvr>

</xml_diff>

<commit_message>
feat(backend & frontend): add proxy pool, restrict PPT uploads to tcekrdcell Drive, add background task manager, and update admin dashboard
</commit_message>
<xml_diff>
--- a/backend/CERTIFICATE_TEMPLATE - APPRECIATION.pptx
+++ b/backend/CERTIFICATE_TEMPLATE - APPRECIATION.pptx
@@ -25,17 +25,17 @@
       <p:italic r:id="rId11"/>
     </p:embeddedFont>
     <p:embeddedFont>
-      <p:font typeface="Calibri" panose="020F0502020204030204" charset="0"/>
+      <p:font typeface="Cardo" panose="02020600000000000000" charset="0"/>
       <p:regular r:id="rId12"/>
       <p:bold r:id="rId13"/>
       <p:italic r:id="rId14"/>
-      <p:boldItalic r:id="rId15"/>
     </p:embeddedFont>
     <p:embeddedFont>
-      <p:font typeface="Cardo" panose="02020600000000000000" charset="0"/>
-      <p:regular r:id="rId16"/>
-      <p:bold r:id="rId17"/>
-      <p:italic r:id="rId18"/>
+      <p:font typeface="Calibri" panose="020F0502020204030204" charset="0"/>
+      <p:regular r:id="rId15"/>
+      <p:bold r:id="rId16"/>
+      <p:italic r:id="rId17"/>
+      <p:boldItalic r:id="rId18"/>
     </p:embeddedFont>
   </p:embeddedFontLst>
   <p:defaultTextStyle>
@@ -4707,7 +4707,31 @@
                 <a:cs typeface="Cardo Bold" panose="02020804080000020003"/>
                 <a:sym typeface="Cardo Bold" panose="02020804080000020003"/>
               </a:rPr>
-              <a:t>Trinity College of Engineering and Technology, Peddapalli,</a:t>
+              <a:t>Trinity College of Engineering and Technology</a:t>
+            </a:r>
+            <a:r>
+              <a:rPr lang="en-IN" altLang="en-US" sz="1705" b="1">
+                <a:solidFill>
+                  <a:srgbClr val="0D1E4A"/>
+                </a:solidFill>
+                <a:latin typeface="Cardo Bold" panose="02020804080000020003"/>
+                <a:ea typeface="Cardo Bold" panose="02020804080000020003"/>
+                <a:cs typeface="Cardo Bold" panose="02020804080000020003"/>
+                <a:sym typeface="Cardo Bold" panose="02020804080000020003"/>
+              </a:rPr>
+              <a:t>- Autonomous</a:t>
+            </a:r>
+            <a:r>
+              <a:rPr lang="en-US" sz="1705" b="1">
+                <a:solidFill>
+                  <a:srgbClr val="0D1E4A"/>
+                </a:solidFill>
+                <a:latin typeface="Cardo Bold" panose="02020804080000020003"/>
+                <a:ea typeface="Cardo Bold" panose="02020804080000020003"/>
+                <a:cs typeface="Cardo Bold" panose="02020804080000020003"/>
+                <a:sym typeface="Cardo Bold" panose="02020804080000020003"/>
+              </a:rPr>
+              <a:t>, Peddapalli,</a:t>
             </a:r>
             <a:r>
               <a:rPr lang="en-US" sz="1705">

</xml_diff>